<commit_message>
feat: add Brigandine to Slide 8 market comps & 3-part visual progression to Slide 9
</commit_message>
<xml_diff>
--- a/ElementalHexTactics_PitchDeck.pptx
+++ b/ElementalHexTactics_PitchDeck.pptx
@@ -1142,7 +1142,7 @@
           <a:lstStyle/>
           <a:p>
             <a:r>
-              <a:t>Vanaris Tactics proved that Toge's audience loves retro tactics. Into the Breach proved how addictive kinetic knockbacks are. Elemental Hex Tactics unites both audiences.</a:t>
+              <a:t>Brigandine proved that players love hex-grid monster commanding on Steam. Vanaris and Into the Breach proved the market for retro tactics and kinetic shoves. Elemental Hex Tactics combines these proven elements into fast 10-minute HD-2D matches.</a:t>
             </a:r>
           </a:p>
         </p:txBody>
@@ -1212,7 +1212,7 @@
           <a:lstStyle/>
           <a:p>
             <a:r>
-              <a:t>For visual and audio production, I'm taking a lean indie approach: I handle 100% of game design and programming, while using the grant to commission specialist freelance pixel artists and an indie composer.</a:t>
+              <a:t>Here is our 3-part visual progression: our verified working prototype in Unity 6, our hex combat reference in Brigandine, and our target HD-2D visual benchmark. This proves we have a working foundation, a clear commercial reference, and a mathematically viable $1,200 asset pipeline.</a:t>
             </a:r>
           </a:p>
         </p:txBody>
@@ -5445,7 +5445,7 @@
               </a:defRPr>
             </a:pPr>
             <a:r>
-              <a:t>• Full Commercial Vision: TGFI demo proves Steam retention, laying the foundation for a full $50k-$150k commercial publishing deal (20+ classes &amp; full campaign).</a:t>
+              <a:t>• Full Commercial Vision: TGFI demo proves Steam retention, laying the groundwork for a full $50k-$150k commercial publishing partnership with Toge (20+ classes &amp; full campaign).</a:t>
             </a:r>
           </a:p>
         </p:txBody>
@@ -8163,7 +8163,7 @@
               </a:defRPr>
             </a:pPr>
             <a:r>
-              <a:t>Procedural encounter routes, emergent environmental chemistry, and diverse squad compositions ensure no two runs feel identical.</a:t>
+              <a:t>Procedural encounter routes, emergent environmental chemistry, and diverse squad combinations ensure no two runs feel identical.</a:t>
             </a:r>
           </a:p>
         </p:txBody>
@@ -8249,8 +8249,8 @@
         </p:nvSpPr>
         <p:spPr>
           <a:xfrm>
-            <a:off x="731520" y="1645920"/>
-            <a:ext cx="3383280" cy="3566160"/>
+            <a:off x="731520" y="1600200"/>
+            <a:ext cx="5212080" cy="1828800"/>
           </a:xfrm>
           <a:prstGeom prst="roundRect">
             <a:avLst/>
@@ -8293,121 +8293,52 @@
               </a:defRPr>
             </a:pPr>
             <a:r>
-              <a:t>Vanaris Tactics (Toge)</a:t>
-            </a:r>
-          </a:p>
-          <a:p>
-            <a:pPr>
-              <a:spcAft>
-                <a:spcPts val="300"/>
-              </a:spcAft>
-              <a:defRPr sz="1150">
-                <a:solidFill>
-                  <a:srgbClr val="F3F4F6"/>
-                </a:solidFill>
-              </a:defRPr>
-            </a:pPr>
-            <a:r>
-              <a:t>Publisher: Toge Productions</a:t>
-            </a:r>
-          </a:p>
-          <a:p>
-            <a:pPr>
-              <a:spcAft>
-                <a:spcPts val="300"/>
-              </a:spcAft>
-              <a:defRPr sz="1150">
-                <a:solidFill>
-                  <a:srgbClr val="F3F4F6"/>
-                </a:solidFill>
-              </a:defRPr>
-            </a:pPr>
-            <a:r>
-              <a:t>Platform: PC / Switch</a:t>
-            </a:r>
-          </a:p>
-          <a:p>
-            <a:pPr>
-              <a:spcAft>
-                <a:spcPts val="300"/>
-              </a:spcAft>
-              <a:defRPr sz="1150">
-                <a:solidFill>
-                  <a:srgbClr val="F3F4F6"/>
-                </a:solidFill>
-              </a:defRPr>
-            </a:pPr>
-          </a:p>
-          <a:p>
-            <a:pPr>
-              <a:spcAft>
-                <a:spcPts val="300"/>
-              </a:spcAft>
-              <a:defRPr sz="1150">
-                <a:solidFill>
-                  <a:srgbClr val="F3F4F6"/>
-                </a:solidFill>
-              </a:defRPr>
-            </a:pPr>
-            <a:r>
-              <a:t>What Players Love:</a:t>
-            </a:r>
-          </a:p>
-          <a:p>
-            <a:pPr>
-              <a:spcAft>
-                <a:spcPts val="300"/>
-              </a:spcAft>
-              <a:defRPr sz="1150">
-                <a:solidFill>
-                  <a:srgbClr val="F3F4F6"/>
-                </a:solidFill>
-              </a:defRPr>
-            </a:pPr>
-            <a:r>
-              <a:t>Classic retro FFT charm, beloved pixel art storytelling.</a:t>
-            </a:r>
-          </a:p>
-          <a:p>
-            <a:pPr>
-              <a:spcAft>
-                <a:spcPts val="300"/>
-              </a:spcAft>
-              <a:defRPr sz="1150">
-                <a:solidFill>
-                  <a:srgbClr val="F3F4F6"/>
-                </a:solidFill>
-              </a:defRPr>
-            </a:pPr>
-          </a:p>
-          <a:p>
-            <a:pPr>
-              <a:spcAft>
-                <a:spcPts val="300"/>
-              </a:spcAft>
-              <a:defRPr sz="1150">
-                <a:solidFill>
-                  <a:srgbClr val="F3F4F6"/>
-                </a:solidFill>
-              </a:defRPr>
-            </a:pPr>
-            <a:r>
-              <a:t>How We Differentiate:</a:t>
-            </a:r>
-          </a:p>
-          <a:p>
-            <a:pPr>
-              <a:spcAft>
-                <a:spcPts val="300"/>
-              </a:spcAft>
-              <a:defRPr sz="1150">
-                <a:solidFill>
-                  <a:srgbClr val="F3F4F6"/>
-                </a:solidFill>
-              </a:defRPr>
-            </a:pPr>
-            <a:r>
-              <a:t>We add fast kinetic shove physics and real-time terrain transformation.</a:t>
+              <a:t>♟️ Brigandine: Runersia (Happinet)</a:t>
+            </a:r>
+          </a:p>
+          <a:p>
+            <a:pPr>
+              <a:spcAft>
+                <a:spcPts val="300"/>
+              </a:spcAft>
+              <a:defRPr sz="1150">
+                <a:solidFill>
+                  <a:srgbClr val="F3F4F6"/>
+                </a:solidFill>
+              </a:defRPr>
+            </a:pPr>
+            <a:r>
+              <a:t>Publisher: Happinet (Very Positive, 1,300+ Steam Reviews)</a:t>
+            </a:r>
+          </a:p>
+          <a:p>
+            <a:pPr>
+              <a:spcAft>
+                <a:spcPts val="300"/>
+              </a:spcAft>
+              <a:defRPr sz="1150">
+                <a:solidFill>
+                  <a:srgbClr val="F3F4F6"/>
+                </a:solidFill>
+              </a:defRPr>
+            </a:pPr>
+            <a:r>
+              <a:t>What Players Love: Deep hex-grid tactics, monster commanding &amp; terrain affinities.</a:t>
+            </a:r>
+          </a:p>
+          <a:p>
+            <a:pPr>
+              <a:spcAft>
+                <a:spcPts val="300"/>
+              </a:spcAft>
+              <a:defRPr sz="1150">
+                <a:solidFill>
+                  <a:srgbClr val="F3F4F6"/>
+                </a:solidFill>
+              </a:defRPr>
+            </a:pPr>
+            <a:r>
+              <a:t>How We Differentiate: Replaces 45-min slow AA battle animations with fast 10-min kinetic skirmishes; transforms passive terrain buffs into Active Terraforming.</a:t>
             </a:r>
           </a:p>
         </p:txBody>
@@ -8420,8 +8351,8 @@
         </p:nvSpPr>
         <p:spPr>
           <a:xfrm>
-            <a:off x="4389120" y="1645920"/>
-            <a:ext cx="3383280" cy="3566160"/>
+            <a:off x="6217920" y="1600200"/>
+            <a:ext cx="5212080" cy="1828800"/>
           </a:xfrm>
           <a:prstGeom prst="roundRect">
             <a:avLst/>
@@ -8464,121 +8395,52 @@
               </a:defRPr>
             </a:pPr>
             <a:r>
-              <a:t>Into the Breach (Subset)</a:t>
-            </a:r>
-          </a:p>
-          <a:p>
-            <a:pPr>
-              <a:spcAft>
-                <a:spcPts val="300"/>
-              </a:spcAft>
-              <a:defRPr sz="1150">
-                <a:solidFill>
-                  <a:srgbClr val="F3F4F6"/>
-                </a:solidFill>
-              </a:defRPr>
-            </a:pPr>
-            <a:r>
-              <a:t>Publisher: Subset Games</a:t>
-            </a:r>
-          </a:p>
-          <a:p>
-            <a:pPr>
-              <a:spcAft>
-                <a:spcPts val="300"/>
-              </a:spcAft>
-              <a:defRPr sz="1150">
-                <a:solidFill>
-                  <a:srgbClr val="F3F4F6"/>
-                </a:solidFill>
-              </a:defRPr>
-            </a:pPr>
-            <a:r>
-              <a:t>Platform: PC / Mobile</a:t>
-            </a:r>
-          </a:p>
-          <a:p>
-            <a:pPr>
-              <a:spcAft>
-                <a:spcPts val="300"/>
-              </a:spcAft>
-              <a:defRPr sz="1150">
-                <a:solidFill>
-                  <a:srgbClr val="F3F4F6"/>
-                </a:solidFill>
-              </a:defRPr>
-            </a:pPr>
-          </a:p>
-          <a:p>
-            <a:pPr>
-              <a:spcAft>
-                <a:spcPts val="300"/>
-              </a:spcAft>
-              <a:defRPr sz="1150">
-                <a:solidFill>
-                  <a:srgbClr val="F3F4F6"/>
-                </a:solidFill>
-              </a:defRPr>
-            </a:pPr>
-            <a:r>
-              <a:t>What Players Love:</a:t>
-            </a:r>
-          </a:p>
-          <a:p>
-            <a:pPr>
-              <a:spcAft>
-                <a:spcPts val="300"/>
-              </a:spcAft>
-              <a:defRPr sz="1150">
-                <a:solidFill>
-                  <a:srgbClr val="F3F4F6"/>
-                </a:solidFill>
-              </a:defRPr>
-            </a:pPr>
-            <a:r>
-              <a:t>Masterpiece of kinetic knockback puzzles.</a:t>
-            </a:r>
-          </a:p>
-          <a:p>
-            <a:pPr>
-              <a:spcAft>
-                <a:spcPts val="300"/>
-              </a:spcAft>
-              <a:defRPr sz="1150">
-                <a:solidFill>
-                  <a:srgbClr val="F3F4F6"/>
-                </a:solidFill>
-              </a:defRPr>
-            </a:pPr>
-          </a:p>
-          <a:p>
-            <a:pPr>
-              <a:spcAft>
-                <a:spcPts val="300"/>
-              </a:spcAft>
-              <a:defRPr sz="1150">
-                <a:solidFill>
-                  <a:srgbClr val="F3F4F6"/>
-                </a:solidFill>
-              </a:defRPr>
-            </a:pPr>
-            <a:r>
-              <a:t>How We Differentiate:</a:t>
-            </a:r>
-          </a:p>
-          <a:p>
-            <a:pPr>
-              <a:spcAft>
-                <a:spcPts val="300"/>
-              </a:spcAft>
-              <a:defRPr sz="1150">
-                <a:solidFill>
-                  <a:srgbClr val="F3F4F6"/>
-                </a:solidFill>
-              </a:defRPr>
-            </a:pPr>
-            <a:r>
-              <a:t>We combine push puzzles with fantasy RPG squad progression, elevation tiers, and land siphoning.</a:t>
+              <a:t>🛡️ Vanaris Tactics (Toge)</a:t>
+            </a:r>
+          </a:p>
+          <a:p>
+            <a:pPr>
+              <a:spcAft>
+                <a:spcPts val="300"/>
+              </a:spcAft>
+              <a:defRPr sz="1150">
+                <a:solidFill>
+                  <a:srgbClr val="F3F4F6"/>
+                </a:solidFill>
+              </a:defRPr>
+            </a:pPr>
+            <a:r>
+              <a:t>Publisher: Toge Productions (Beloved Retro Tactics)</a:t>
+            </a:r>
+          </a:p>
+          <a:p>
+            <a:pPr>
+              <a:spcAft>
+                <a:spcPts val="300"/>
+              </a:spcAft>
+              <a:defRPr sz="1150">
+                <a:solidFill>
+                  <a:srgbClr val="F3F4F6"/>
+                </a:solidFill>
+              </a:defRPr>
+            </a:pPr>
+            <a:r>
+              <a:t>What Players Love: Classic retro FFT charm, beloved pixel art storytelling.</a:t>
+            </a:r>
+          </a:p>
+          <a:p>
+            <a:pPr>
+              <a:spcAft>
+                <a:spcPts val="300"/>
+              </a:spcAft>
+              <a:defRPr sz="1150">
+                <a:solidFill>
+                  <a:srgbClr val="F3F4F6"/>
+                </a:solidFill>
+              </a:defRPr>
+            </a:pPr>
+            <a:r>
+              <a:t>How We Differentiate: Adds 3D multi-level hex elevations, kinetic shove impact physics, and real-time elemental landscape destruction.</a:t>
             </a:r>
           </a:p>
         </p:txBody>
@@ -8591,179 +8453,8 @@
         </p:nvSpPr>
         <p:spPr>
           <a:xfrm>
-            <a:off x="8046720" y="1645920"/>
-            <a:ext cx="3383280" cy="3566160"/>
-          </a:xfrm>
-          <a:prstGeom prst="roundRect">
-            <a:avLst/>
-          </a:prstGeom>
-          <a:solidFill>
-            <a:srgbClr val="161B22"/>
-          </a:solidFill>
-          <a:ln w="19050">
-            <a:solidFill>
-              <a:srgbClr val="30363D"/>
-            </a:solidFill>
-          </a:ln>
-        </p:spPr>
-        <p:style>
-          <a:lnRef idx="1">
-            <a:schemeClr val="accent1"/>
-          </a:lnRef>
-          <a:fillRef idx="3">
-            <a:schemeClr val="accent1"/>
-          </a:fillRef>
-          <a:effectRef idx="2">
-            <a:schemeClr val="accent1"/>
-          </a:effectRef>
-          <a:fontRef idx="minor">
-            <a:schemeClr val="lt1"/>
-          </a:fontRef>
-        </p:style>
-        <p:txBody>
-          <a:bodyPr rtlCol="0" anchor="ctr" wrap="square" lIns="182880" rIns="182880" tIns="164592" bIns="164592"/>
-          <a:lstStyle/>
-          <a:p>
-            <a:pPr algn="ctr">
-              <a:spcAft>
-                <a:spcPts val="500"/>
-              </a:spcAft>
-              <a:defRPr b="1" sz="1350">
-                <a:solidFill>
-                  <a:srgbClr val="F59E0B"/>
-                </a:solidFill>
-              </a:defRPr>
-            </a:pPr>
-            <a:r>
-              <a:t>Triangle Strategy (Square Enix)</a:t>
-            </a:r>
-          </a:p>
-          <a:p>
-            <a:pPr>
-              <a:spcAft>
-                <a:spcPts val="300"/>
-              </a:spcAft>
-              <a:defRPr sz="1150">
-                <a:solidFill>
-                  <a:srgbClr val="F3F4F6"/>
-                </a:solidFill>
-              </a:defRPr>
-            </a:pPr>
-            <a:r>
-              <a:t>Publisher: Square Enix</a:t>
-            </a:r>
-          </a:p>
-          <a:p>
-            <a:pPr>
-              <a:spcAft>
-                <a:spcPts val="300"/>
-              </a:spcAft>
-              <a:defRPr sz="1150">
-                <a:solidFill>
-                  <a:srgbClr val="F3F4F6"/>
-                </a:solidFill>
-              </a:defRPr>
-            </a:pPr>
-            <a:r>
-              <a:t>Platform: PC / Switch</a:t>
-            </a:r>
-          </a:p>
-          <a:p>
-            <a:pPr>
-              <a:spcAft>
-                <a:spcPts val="300"/>
-              </a:spcAft>
-              <a:defRPr sz="1150">
-                <a:solidFill>
-                  <a:srgbClr val="F3F4F6"/>
-                </a:solidFill>
-              </a:defRPr>
-            </a:pPr>
-          </a:p>
-          <a:p>
-            <a:pPr>
-              <a:spcAft>
-                <a:spcPts val="300"/>
-              </a:spcAft>
-              <a:defRPr sz="1150">
-                <a:solidFill>
-                  <a:srgbClr val="F3F4F6"/>
-                </a:solidFill>
-              </a:defRPr>
-            </a:pPr>
-            <a:r>
-              <a:t>What Players Love:</a:t>
-            </a:r>
-          </a:p>
-          <a:p>
-            <a:pPr>
-              <a:spcAft>
-                <a:spcPts val="300"/>
-              </a:spcAft>
-              <a:defRPr sz="1150">
-                <a:solidFill>
-                  <a:srgbClr val="F3F4F6"/>
-                </a:solidFill>
-              </a:defRPr>
-            </a:pPr>
-            <a:r>
-              <a:t>HD-2D tactical presentation.</a:t>
-            </a:r>
-          </a:p>
-          <a:p>
-            <a:pPr>
-              <a:spcAft>
-                <a:spcPts val="300"/>
-              </a:spcAft>
-              <a:defRPr sz="1150">
-                <a:solidFill>
-                  <a:srgbClr val="F3F4F6"/>
-                </a:solidFill>
-              </a:defRPr>
-            </a:pPr>
-          </a:p>
-          <a:p>
-            <a:pPr>
-              <a:spcAft>
-                <a:spcPts val="300"/>
-              </a:spcAft>
-              <a:defRPr sz="1150">
-                <a:solidFill>
-                  <a:srgbClr val="F3F4F6"/>
-                </a:solidFill>
-              </a:defRPr>
-            </a:pPr>
-            <a:r>
-              <a:t>How We Differentiate:</a:t>
-            </a:r>
-          </a:p>
-          <a:p>
-            <a:pPr>
-              <a:spcAft>
-                <a:spcPts val="300"/>
-              </a:spcAft>
-              <a:defRPr sz="1150">
-                <a:solidFill>
-                  <a:srgbClr val="F3F4F6"/>
-                </a:solidFill>
-              </a:defRPr>
-            </a:pPr>
-            <a:r>
-              <a:t>Faster 10-minute skirmishes designed for modern players with zero level-grinding and deeper terrain chemistry.</a:t>
-            </a:r>
-          </a:p>
-        </p:txBody>
-      </p:sp>
-      <p:sp>
-        <p:nvSpPr>
-          <p:cNvPr id="6" name="Rounded Rectangle 5"/>
-          <p:cNvSpPr/>
-          <p:nvPr/>
-        </p:nvSpPr>
-        <p:spPr>
-          <a:xfrm>
-            <a:off x="731520" y="5440680"/>
-            <a:ext cx="10698480" cy="822960"/>
+            <a:off x="731520" y="3566160"/>
+            <a:ext cx="5212080" cy="1828800"/>
           </a:xfrm>
           <a:prstGeom prst="roundRect">
             <a:avLst/>
@@ -8806,6 +8497,210 @@
               </a:defRPr>
             </a:pPr>
             <a:r>
+              <a:t>💥 Into the Breach (Subset)</a:t>
+            </a:r>
+          </a:p>
+          <a:p>
+            <a:pPr>
+              <a:spcAft>
+                <a:spcPts val="300"/>
+              </a:spcAft>
+              <a:defRPr sz="1150">
+                <a:solidFill>
+                  <a:srgbClr val="F3F4F6"/>
+                </a:solidFill>
+              </a:defRPr>
+            </a:pPr>
+            <a:r>
+              <a:t>Publisher: Subset Games (Overwhelmingly Positive)</a:t>
+            </a:r>
+          </a:p>
+          <a:p>
+            <a:pPr>
+              <a:spcAft>
+                <a:spcPts val="300"/>
+              </a:spcAft>
+              <a:defRPr sz="1150">
+                <a:solidFill>
+                  <a:srgbClr val="F3F4F6"/>
+                </a:solidFill>
+              </a:defRPr>
+            </a:pPr>
+            <a:r>
+              <a:t>What Players Love: Masterpiece of kinetic knockback puzzles.</a:t>
+            </a:r>
+          </a:p>
+          <a:p>
+            <a:pPr>
+              <a:spcAft>
+                <a:spcPts val="300"/>
+              </a:spcAft>
+              <a:defRPr sz="1150">
+                <a:solidFill>
+                  <a:srgbClr val="F3F4F6"/>
+                </a:solidFill>
+              </a:defRPr>
+            </a:pPr>
+            <a:r>
+              <a:t>How We Differentiate: Marries push puzzles with fantasy RPG squad progression, elevation tiers, and land siphoning for Titan cataclysms.</a:t>
+            </a:r>
+          </a:p>
+        </p:txBody>
+      </p:sp>
+      <p:sp>
+        <p:nvSpPr>
+          <p:cNvPr id="6" name="Rounded Rectangle 5"/>
+          <p:cNvSpPr/>
+          <p:nvPr/>
+        </p:nvSpPr>
+        <p:spPr>
+          <a:xfrm>
+            <a:off x="6217920" y="3566160"/>
+            <a:ext cx="5212080" cy="1828800"/>
+          </a:xfrm>
+          <a:prstGeom prst="roundRect">
+            <a:avLst/>
+          </a:prstGeom>
+          <a:solidFill>
+            <a:srgbClr val="161B22"/>
+          </a:solidFill>
+          <a:ln w="19050">
+            <a:solidFill>
+              <a:srgbClr val="06B6D4"/>
+            </a:solidFill>
+          </a:ln>
+        </p:spPr>
+        <p:style>
+          <a:lnRef idx="1">
+            <a:schemeClr val="accent1"/>
+          </a:lnRef>
+          <a:fillRef idx="3">
+            <a:schemeClr val="accent1"/>
+          </a:fillRef>
+          <a:effectRef idx="2">
+            <a:schemeClr val="accent1"/>
+          </a:effectRef>
+          <a:fontRef idx="minor">
+            <a:schemeClr val="lt1"/>
+          </a:fontRef>
+        </p:style>
+        <p:txBody>
+          <a:bodyPr rtlCol="0" anchor="ctr" wrap="square" lIns="182880" rIns="182880" tIns="164592" bIns="164592"/>
+          <a:lstStyle/>
+          <a:p>
+            <a:pPr algn="ctr">
+              <a:spcAft>
+                <a:spcPts val="500"/>
+              </a:spcAft>
+              <a:defRPr b="1" sz="1350">
+                <a:solidFill>
+                  <a:srgbClr val="06B6D4"/>
+                </a:solidFill>
+              </a:defRPr>
+            </a:pPr>
+            <a:r>
+              <a:t>⚔️ Triangle Strategy (Square Enix)</a:t>
+            </a:r>
+          </a:p>
+          <a:p>
+            <a:pPr>
+              <a:spcAft>
+                <a:spcPts val="300"/>
+              </a:spcAft>
+              <a:defRPr sz="1150">
+                <a:solidFill>
+                  <a:srgbClr val="F3F4F6"/>
+                </a:solidFill>
+              </a:defRPr>
+            </a:pPr>
+            <a:r>
+              <a:t>Publisher: Square Enix (HD-2D Tactical RPG)</a:t>
+            </a:r>
+          </a:p>
+          <a:p>
+            <a:pPr>
+              <a:spcAft>
+                <a:spcPts val="300"/>
+              </a:spcAft>
+              <a:defRPr sz="1150">
+                <a:solidFill>
+                  <a:srgbClr val="F3F4F6"/>
+                </a:solidFill>
+              </a:defRPr>
+            </a:pPr>
+            <a:r>
+              <a:t>What Players Love: Modern HD-2D presentation &amp; elemental interactions.</a:t>
+            </a:r>
+          </a:p>
+          <a:p>
+            <a:pPr>
+              <a:spcAft>
+                <a:spcPts val="300"/>
+              </a:spcAft>
+              <a:defRPr sz="1150">
+                <a:solidFill>
+                  <a:srgbClr val="F3F4F6"/>
+                </a:solidFill>
+              </a:defRPr>
+            </a:pPr>
+            <a:r>
+              <a:t>How We Differentiate: Snappy 10-minute skirmishes designed for modern indie players with zero level-grinding and deeper terrain chemistry.</a:t>
+            </a:r>
+          </a:p>
+        </p:txBody>
+      </p:sp>
+      <p:sp>
+        <p:nvSpPr>
+          <p:cNvPr id="7" name="Rounded Rectangle 6"/>
+          <p:cNvSpPr/>
+          <p:nvPr/>
+        </p:nvSpPr>
+        <p:spPr>
+          <a:xfrm>
+            <a:off x="731520" y="5532120"/>
+            <a:ext cx="10698480" cy="777240"/>
+          </a:xfrm>
+          <a:prstGeom prst="roundRect">
+            <a:avLst/>
+          </a:prstGeom>
+          <a:solidFill>
+            <a:srgbClr val="161B22"/>
+          </a:solidFill>
+          <a:ln w="19050">
+            <a:solidFill>
+              <a:srgbClr val="F59E0B"/>
+            </a:solidFill>
+          </a:ln>
+        </p:spPr>
+        <p:style>
+          <a:lnRef idx="1">
+            <a:schemeClr val="accent1"/>
+          </a:lnRef>
+          <a:fillRef idx="3">
+            <a:schemeClr val="accent1"/>
+          </a:fillRef>
+          <a:effectRef idx="2">
+            <a:schemeClr val="accent1"/>
+          </a:effectRef>
+          <a:fontRef idx="minor">
+            <a:schemeClr val="lt1"/>
+          </a:fontRef>
+        </p:style>
+        <p:txBody>
+          <a:bodyPr rtlCol="0" anchor="ctr" wrap="square" lIns="182880" rIns="182880" tIns="164592" bIns="164592"/>
+          <a:lstStyle/>
+          <a:p>
+            <a:pPr algn="ctr">
+              <a:spcAft>
+                <a:spcPts val="500"/>
+              </a:spcAft>
+              <a:defRPr b="1" sz="1350">
+                <a:solidFill>
+                  <a:srgbClr val="F59E0B"/>
+                </a:solidFill>
+              </a:defRPr>
+            </a:pPr>
+            <a:r>
               <a:t>🎯 The Market Opportunity</a:t>
             </a:r>
           </a:p>
@@ -8821,7 +8716,7 @@
               </a:defRPr>
             </a:pPr>
             <a:r>
-              <a:t>Players love Into the Breach's puzzle clarity and Final Fantasy Tactics' fantasy flavor—Elemental Hex Tactics marries both into snappy 10-minute matches.</a:t>
+              <a:t>Players love Brigandine's hex-grid monster fantasy and Into the Breach's puzzle clarity—Elemental Hex Tactics marries both into snappy 10-minute HD-2D matches with active terraforming.</a:t>
             </a:r>
           </a:p>
         </p:txBody>
@@ -8882,7 +8777,7 @@
               </a:defRPr>
             </a:pPr>
             <a:r>
-              <a:t>TOGE GAME FUND INITIATIVE (TGFI) PITCH</a:t>
+              <a:t>ART DIRECTION &amp; PRODUCTION BENCHMARK</a:t>
             </a:r>
           </a:p>
           <a:p>
@@ -8894,7 +8789,7 @@
               </a:defRPr>
             </a:pPr>
             <a:r>
-              <a:t>Visual Target: HD-2D Diorama &amp; Production Benchmark</a:t>
+              <a:t>Visual Target: HD-2D Aesthetic &amp; Reference Pipeline</a:t>
             </a:r>
           </a:p>
         </p:txBody>
@@ -8908,7 +8803,7 @@
         <p:spPr>
           <a:xfrm>
             <a:off x="731520" y="1645920"/>
-            <a:ext cx="5212080" cy="2240280"/>
+            <a:ext cx="5303520" cy="2240280"/>
           </a:xfrm>
           <a:prstGeom prst="roundRect">
             <a:avLst/>
@@ -9009,8 +8904,8 @@
         </p:nvSpPr>
         <p:spPr>
           <a:xfrm>
-            <a:off x="6217920" y="1645920"/>
-            <a:ext cx="5212080" cy="2240280"/>
+            <a:off x="731520" y="4160520"/>
+            <a:ext cx="5303520" cy="2103120"/>
           </a:xfrm>
           <a:prstGeom prst="roundRect">
             <a:avLst/>
@@ -9103,165 +8998,30 @@
           </a:p>
         </p:txBody>
       </p:sp>
-      <p:sp>
-        <p:nvSpPr>
-          <p:cNvPr id="5" name="Rounded Rectangle 4"/>
-          <p:cNvSpPr/>
+      <p:pic>
+        <p:nvPicPr>
+          <p:cNvPr id="5" name="Picture 4" descr="slide9_visual_benchmark.png"/>
+          <p:cNvPicPr>
+            <a:picLocks noChangeAspect="1"/>
+          </p:cNvPicPr>
           <p:nvPr/>
-        </p:nvSpPr>
+        </p:nvPicPr>
+        <p:blipFill>
+          <a:blip r:embed="rId2"/>
+          <a:stretch>
+            <a:fillRect/>
+          </a:stretch>
+        </p:blipFill>
         <p:spPr>
           <a:xfrm>
-            <a:off x="731520" y="4160520"/>
-            <a:ext cx="5212080" cy="2103120"/>
+            <a:off x="6400800" y="1463040"/>
+            <a:ext cx="4214191" cy="4846320"/>
           </a:xfrm>
-          <a:prstGeom prst="roundRect">
+          <a:prstGeom prst="rect">
             <a:avLst/>
           </a:prstGeom>
-          <a:solidFill>
-            <a:srgbClr val="161B22"/>
-          </a:solidFill>
-          <a:ln w="19050">
-            <a:solidFill>
-              <a:srgbClr val="30363D"/>
-            </a:solidFill>
-          </a:ln>
         </p:spPr>
-        <p:style>
-          <a:lnRef idx="1">
-            <a:schemeClr val="accent1"/>
-          </a:lnRef>
-          <a:fillRef idx="3">
-            <a:schemeClr val="accent1"/>
-          </a:fillRef>
-          <a:effectRef idx="2">
-            <a:schemeClr val="accent1"/>
-          </a:effectRef>
-          <a:fontRef idx="minor">
-            <a:schemeClr val="lt1"/>
-          </a:fontRef>
-        </p:style>
-        <p:txBody>
-          <a:bodyPr rtlCol="0" anchor="ctr" wrap="square" lIns="182880" rIns="182880" tIns="164592" bIns="164592"/>
-          <a:lstStyle/>
-          <a:p>
-            <a:pPr algn="ctr">
-              <a:spcAft>
-                <a:spcPts val="500"/>
-              </a:spcAft>
-              <a:defRPr b="1" sz="1350">
-                <a:solidFill>
-                  <a:srgbClr val="F59E0B"/>
-                </a:solidFill>
-              </a:defRPr>
-            </a:pPr>
-            <a:r>
-              <a:t>🎵 Audio Production: Freelance OST</a:t>
-            </a:r>
-          </a:p>
-          <a:p>
-            <a:pPr>
-              <a:spcAft>
-                <a:spcPts val="300"/>
-              </a:spcAft>
-              <a:defRPr sz="1150">
-                <a:solidFill>
-                  <a:srgbClr val="F3F4F6"/>
-                </a:solidFill>
-              </a:defRPr>
-            </a:pPr>
-            <a:r>
-              <a:t>• Procedural sound engine already active in Unity 6 for impacts &amp; spells.</a:t>
-            </a:r>
-          </a:p>
-          <a:p>
-            <a:pPr>
-              <a:spcAft>
-                <a:spcPts val="300"/>
-              </a:spcAft>
-              <a:defRPr sz="1150">
-                <a:solidFill>
-                  <a:srgbClr val="F3F4F6"/>
-                </a:solidFill>
-              </a:defRPr>
-            </a:pPr>
-            <a:r>
-              <a:t>• Grant funds commission an indie composer for 2 original orchestral tactical battle themes and custom elemental SFX.</a:t>
-            </a:r>
-          </a:p>
-        </p:txBody>
-      </p:sp>
-      <p:sp>
-        <p:nvSpPr>
-          <p:cNvPr id="6" name="Rounded Rectangle 5"/>
-          <p:cNvSpPr/>
-          <p:nvPr/>
-        </p:nvSpPr>
-        <p:spPr>
-          <a:xfrm>
-            <a:off x="6217920" y="4160520"/>
-            <a:ext cx="5212080" cy="2103120"/>
-          </a:xfrm>
-          <a:prstGeom prst="roundRect">
-            <a:avLst/>
-          </a:prstGeom>
-          <a:solidFill>
-            <a:srgbClr val="161B22"/>
-          </a:solidFill>
-          <a:ln w="19050">
-            <a:solidFill>
-              <a:srgbClr val="30363D"/>
-            </a:solidFill>
-          </a:ln>
-        </p:spPr>
-        <p:style>
-          <a:lnRef idx="1">
-            <a:schemeClr val="accent1"/>
-          </a:lnRef>
-          <a:fillRef idx="3">
-            <a:schemeClr val="accent1"/>
-          </a:fillRef>
-          <a:effectRef idx="2">
-            <a:schemeClr val="accent1"/>
-          </a:effectRef>
-          <a:fontRef idx="minor">
-            <a:schemeClr val="lt1"/>
-          </a:fontRef>
-        </p:style>
-        <p:txBody>
-          <a:bodyPr rtlCol="0" anchor="ctr" wrap="square" lIns="182880" rIns="182880" tIns="164592" bIns="164592"/>
-          <a:lstStyle/>
-          <a:p>
-            <a:pPr algn="ctr">
-              <a:spcAft>
-                <a:spcPts val="500"/>
-              </a:spcAft>
-              <a:defRPr b="1" sz="1350">
-                <a:solidFill>
-                  <a:srgbClr val="F59E0B"/>
-                </a:solidFill>
-              </a:defRPr>
-            </a:pPr>
-            <a:r>
-              <a:t>💥 Tactile Combat Juice</a:t>
-            </a:r>
-          </a:p>
-          <a:p>
-            <a:pPr>
-              <a:spcAft>
-                <a:spcPts val="300"/>
-              </a:spcAft>
-              <a:defRPr sz="1150">
-                <a:solidFill>
-                  <a:srgbClr val="F3F4F6"/>
-                </a:solidFill>
-              </a:defRPr>
-            </a:pPr>
-            <a:r>
-              <a:t>Trauma-based decaying screen shake on wall collisions, particle sparks on terrain ignition, and floating combat text ensure every hit feels impactful.</a:t>
-            </a:r>
-          </a:p>
-        </p:txBody>
-      </p:sp>
+      </p:pic>
     </p:spTree>
   </p:cSld>
   <p:clrMapOvr>

</xml_diff>

<commit_message>
refactor: update PPTX with Master & Monster dual-command positioning and streamlined tactical pacing
</commit_message>
<xml_diff>
--- a/ElementalHexTactics_PitchDeck.pptx
+++ b/ElementalHexTactics_PitchDeck.pptx
@@ -512,7 +512,7 @@
           <a:lstStyle/>
           <a:p>
             <a:r>
-              <a:t>Hi Kris and the Toge team, I'm Elang, a solo indie developer from Indonesia. Today I'm pitching Elemental Hex Tactics, a 2.5D tactical RPG inspired by classic JRPGs and Into the Breach, where the terrain itself is your greatest weapon.</a:t>
+              <a:t>Hi Kris and the Toge team, I'm Elang, a solo indie developer from Indonesia. Today I'm pitching Elemental Hex Tactics, a 2.5D tactical RPG inspired by Brigandine and Final Fantasy Tactics, where players directly command both human Masters and monster cohorts while using the terrain itself as an interactive weapon.</a:t>
             </a:r>
           </a:p>
         </p:txBody>
@@ -722,7 +722,7 @@
           <a:lstStyle/>
           <a:p>
             <a:r>
-              <a:t>Our core loop creates a natural tactical rhythm: you light the ground on fire, knock an enemy into it, stand in the fire to buff your dragon, drain the land for energy, and wipe out the enemy squad with a volcanic cataclysm.</a:t>
+              <a:t>Our core loop connects Master and Monster: your Master alters the terrain and pushes enemies, while your Monster holds the frontline, buffs itself on the elemental tiles, drains the land for energy, and wipes out the opposition with Cataclysms.</a:t>
             </a:r>
           </a:p>
         </p:txBody>
@@ -792,7 +792,7 @@
           <a:lstStyle/>
           <a:p>
             <a:r>
-              <a:t>We focus on three gameplay pillars: offensive terraforming with elemental magic, Titans that feed on the battlefield, and kinetic displacement that makes positioning lethal.</a:t>
+              <a:t>We focus on three gameplay pillars: offensive terraforming, direct dual-control of Masters and Monster cohorts, and kinetic displacement that makes positioning lethal.</a:t>
             </a:r>
           </a:p>
         </p:txBody>
@@ -862,7 +862,7 @@
           <a:lstStyle/>
           <a:p>
             <a:r>
-              <a:t>We aren't pitching an unproven idea. The vertical slice is completely built, tested, and playable today. You can run the Windows build from my submission and play through an entire battle.</a:t>
+              <a:t>We aren't pitching an unproven idea. The vertical slice is completely built, tested, and playable today. You can run the Windows build from my submission and experience the Master and Titan synergy firsthand.</a:t>
             </a:r>
           </a:p>
         </p:txBody>
@@ -932,7 +932,7 @@
           <a:lstStyle/>
           <a:p>
             <a:r>
-              <a:t>We solved two major tactical RPG frustrations: Ghost UI eliminates cognitive overload by previewing reactions before casting, and hybrid attack-spells remove setup tax so every single turn feels impactful.</a:t>
+              <a:t>We solved two major tactical RPG frustrations: Ghost UI eliminates cognitive overload by previewing reactions before casting, and hybrid attack-spells remove setup tax so every turn feels impactful.</a:t>
             </a:r>
           </a:p>
         </p:txBody>
@@ -1002,7 +1002,7 @@
           <a:lstStyle/>
           <a:p>
             <a:r>
-              <a:t>Every squad features asymmetric roles: your fragile Commander shapes the terrain and controls space, while your Titan holds the frontline, absorbs environmental energy, and delivers the finishing blows.</a:t>
+              <a:t>Every squad features asymmetric roles: your fragile Master shapes the terrain and controls space, while your Monster holds the frontline, absorbs environmental energy, and delivers the finishing blows.</a:t>
             </a:r>
           </a:p>
         </p:txBody>
@@ -1072,7 +1072,7 @@
           <a:lstStyle/>
           <a:p>
             <a:r>
-              <a:t>Beyond individual battles, the campaign features a node-based expedition map with spellbook upgrades, elemental titan customization, and zero level grinding.</a:t>
+              <a:t>Beyond individual battles, the campaign features a node-based expedition map with spellbook upgrades, monster squad customization, and zero level grinding.</a:t>
             </a:r>
           </a:p>
         </p:txBody>
@@ -1142,7 +1142,7 @@
           <a:lstStyle/>
           <a:p>
             <a:r>
-              <a:t>Brigandine proved that players love hex-grid monster commanding on Steam. Vanaris and Into the Breach proved the market for retro tactics and kinetic shoves. Elemental Hex Tactics combines these proven elements into fast 10-minute HD-2D matches.</a:t>
+              <a:t>Brigandine proved that players love hex-grid monster commanding on Steam. Vanaris and Into the Breach proved the market for retro tactics and kinetic shoves. Elemental Hex Tactics combines these proven elements into streamlined, deliberate HD-2D matches.</a:t>
             </a:r>
           </a:p>
         </p:txBody>
@@ -4286,7 +4286,7 @@
               </a:defRPr>
             </a:pPr>
             <a:r>
-              <a:t>"Into the Breach meets Final Fantasy Tactics"</a:t>
+              <a:t>"Brigandine meets Final Fantasy Tactics"</a:t>
             </a:r>
           </a:p>
           <a:p>
@@ -4301,7 +4301,7 @@
               </a:defRPr>
             </a:pPr>
             <a:r>
-              <a:t>A fast-paced 2.5D tactical RPG where the battlefield itself is an interactive chemical weapon. Alter 3D terrain with elemental magic, shove enemies into hazards, and harvest the land to fuel colossal Titan abilities.</a:t>
+              <a:t>A rich, streamlined 2.5D tactical RPG where players directly command both Human Masters and colossal Monsters. Reshape 3D terrain with elemental magic, shove enemies into hazards, and harvest the land to unleash devastating Titan Cataclysms.</a:t>
             </a:r>
           </a:p>
           <a:p>
@@ -4898,7 +4898,7 @@
               </a:defRPr>
             </a:pPr>
             <a:r>
-              <a:t>Core engine, hex grid math, kinetic displacement, and land-siphoning loops are ALREADY complete (Month 0). Months 1–6 are strictly for content, art pipeline, and AI tuning.</a:t>
+              <a:t>Core combat engine, hex grid math, kinetic displacement, and land-siphoning loops are ALREADY complete (Month 0). Months 1–6 are strictly for content, art pipeline, and AI tuning.</a:t>
             </a:r>
           </a:p>
         </p:txBody>
@@ -5445,7 +5445,7 @@
               </a:defRPr>
             </a:pPr>
             <a:r>
-              <a:t>• Full Commercial Vision: TGFI demo proves Steam retention, laying the groundwork for a full $50k-$150k commercial publishing partnership with Toge (20+ classes &amp; full campaign).</a:t>
+              <a:t>• Full Commercial Vision: TGFI demo proves Steam retention, laying the groundwork for a full $50k-$150k commercial publishing partnership with Toge (20+ classes &amp; full Master-Monster campaign).</a:t>
             </a:r>
           </a:p>
         </p:txBody>
@@ -5590,7 +5590,7 @@
               </a:defRPr>
             </a:pPr>
             <a:r>
-              <a:t>1. Infuse (Terraform)   ➔   2. Attune (Adapt)   ➔   3. Consume (Unleash)</a:t>
+              <a:t>1. Master Infuses (Terraform)   ➔   2. Monster Attunes (Adapt)   ➔   3. Monster Consumes (Unleash)</a:t>
             </a:r>
           </a:p>
         </p:txBody>
@@ -5647,49 +5647,49 @@
               </a:defRPr>
             </a:pPr>
             <a:r>
-              <a:t>🔥 1. Infuse (Terraform)</a:t>
-            </a:r>
-          </a:p>
-          <a:p>
-            <a:pPr>
-              <a:spcAft>
-                <a:spcPts val="300"/>
-              </a:spcAft>
-              <a:defRPr sz="1150">
-                <a:solidFill>
-                  <a:srgbClr val="F3F4F6"/>
-                </a:solidFill>
-              </a:defRPr>
-            </a:pPr>
-            <a:r>
-              <a:t>Spells physically change the ground in real-time.</a:t>
-            </a:r>
-          </a:p>
-          <a:p>
-            <a:pPr>
-              <a:spcAft>
-                <a:spcPts val="300"/>
-              </a:spcAft>
-              <a:defRPr sz="1150">
-                <a:solidFill>
-                  <a:srgbClr val="F3F4F6"/>
-                </a:solidFill>
-              </a:defRPr>
-            </a:pPr>
-          </a:p>
-          <a:p>
-            <a:pPr>
-              <a:spcAft>
-                <a:spcPts val="300"/>
-              </a:spcAft>
-              <a:defRPr sz="1150">
-                <a:solidFill>
-                  <a:srgbClr val="F3F4F6"/>
-                </a:solidFill>
-              </a:defRPr>
-            </a:pPr>
-            <a:r>
-              <a:t>Fireballs burn lush grass into molten lava; water blasts douse flames and create concealing steam clouds.</a:t>
+              <a:t>🧙 1. Master Infuses (Terraform)</a:t>
+            </a:r>
+          </a:p>
+          <a:p>
+            <a:pPr>
+              <a:spcAft>
+                <a:spcPts val="300"/>
+              </a:spcAft>
+              <a:defRPr sz="1150">
+                <a:solidFill>
+                  <a:srgbClr val="F3F4F6"/>
+                </a:solidFill>
+              </a:defRPr>
+            </a:pPr>
+            <a:r>
+              <a:t>Human Masters reshape the battlefield with magic.</a:t>
+            </a:r>
+          </a:p>
+          <a:p>
+            <a:pPr>
+              <a:spcAft>
+                <a:spcPts val="300"/>
+              </a:spcAft>
+              <a:defRPr sz="1150">
+                <a:solidFill>
+                  <a:srgbClr val="F3F4F6"/>
+                </a:solidFill>
+              </a:defRPr>
+            </a:pPr>
+          </a:p>
+          <a:p>
+            <a:pPr>
+              <a:spcAft>
+                <a:spcPts val="300"/>
+              </a:spcAft>
+              <a:defRPr sz="1150">
+                <a:solidFill>
+                  <a:srgbClr val="F3F4F6"/>
+                </a:solidFill>
+              </a:defRPr>
+            </a:pPr>
+            <a:r>
+              <a:t>Fireballs scorch grass into molten lava moats; water blasts douse flames and create concealing steam clouds.</a:t>
             </a:r>
           </a:p>
         </p:txBody>
@@ -5746,49 +5746,49 @@
               </a:defRPr>
             </a:pPr>
             <a:r>
-              <a:t>🌊 2. Attune (Adapt)</a:t>
-            </a:r>
-          </a:p>
-          <a:p>
-            <a:pPr>
-              <a:spcAft>
-                <a:spcPts val="300"/>
-              </a:spcAft>
-              <a:defRPr sz="1150">
-                <a:solidFill>
-                  <a:srgbClr val="F3F4F6"/>
-                </a:solidFill>
-              </a:defRPr>
-            </a:pPr>
-            <a:r>
-              <a:t>Units gain dynamic passive buffs matching the ground beneath them.</a:t>
-            </a:r>
-          </a:p>
-          <a:p>
-            <a:pPr>
-              <a:spcAft>
-                <a:spcPts val="300"/>
-              </a:spcAft>
-              <a:defRPr sz="1150">
-                <a:solidFill>
-                  <a:srgbClr val="F3F4F6"/>
-                </a:solidFill>
-              </a:defRPr>
-            </a:pPr>
-          </a:p>
-          <a:p>
-            <a:pPr>
-              <a:spcAft>
-                <a:spcPts val="300"/>
-              </a:spcAft>
-              <a:defRPr sz="1150">
-                <a:solidFill>
-                  <a:srgbClr val="F3F4F6"/>
-                </a:solidFill>
-              </a:defRPr>
-            </a:pPr>
-            <a:r>
-              <a:t>Standing on lava grants fire units +2 ATK and complete burn immunity.</a:t>
+              <a:t>🐉 2. Monster Attunes (Adapt)</a:t>
+            </a:r>
+          </a:p>
+          <a:p>
+            <a:pPr>
+              <a:spcAft>
+                <a:spcPts val="300"/>
+              </a:spcAft>
+              <a:defRPr sz="1150">
+                <a:solidFill>
+                  <a:srgbClr val="F3F4F6"/>
+                </a:solidFill>
+              </a:defRPr>
+            </a:pPr>
+            <a:r>
+              <a:t>Allied Monsters thrive in their native elements.</a:t>
+            </a:r>
+          </a:p>
+          <a:p>
+            <a:pPr>
+              <a:spcAft>
+                <a:spcPts val="300"/>
+              </a:spcAft>
+              <a:defRPr sz="1150">
+                <a:solidFill>
+                  <a:srgbClr val="F3F4F6"/>
+                </a:solidFill>
+              </a:defRPr>
+            </a:pPr>
+          </a:p>
+          <a:p>
+            <a:pPr>
+              <a:spcAft>
+                <a:spcPts val="300"/>
+              </a:spcAft>
+              <a:defRPr sz="1150">
+                <a:solidFill>
+                  <a:srgbClr val="F3F4F6"/>
+                </a:solidFill>
+              </a:defRPr>
+            </a:pPr>
+            <a:r>
+              <a:t>Standing on lava grants fire beasts +2 ATK and complete burn immunity. Positioning monsters on matching tiles is key.</a:t>
             </a:r>
           </a:p>
         </p:txBody>
@@ -5845,22 +5845,22 @@
               </a:defRPr>
             </a:pPr>
             <a:r>
-              <a:t>⚡ 3. Consume (Unleash)</a:t>
-            </a:r>
-          </a:p>
-          <a:p>
-            <a:pPr>
-              <a:spcAft>
-                <a:spcPts val="300"/>
-              </a:spcAft>
-              <a:defRPr sz="1150">
-                <a:solidFill>
-                  <a:srgbClr val="F3F4F6"/>
-                </a:solidFill>
-              </a:defRPr>
-            </a:pPr>
-            <a:r>
-              <a:t>Titans siphon active lava or lakes, turning the land into Barren Earth.</a:t>
+              <a:t>⚡ 3. Monster Consumes (Unleash)</a:t>
+            </a:r>
+          </a:p>
+          <a:p>
+            <a:pPr>
+              <a:spcAft>
+                <a:spcPts val="300"/>
+              </a:spcAft>
+              <a:defRPr sz="1150">
+                <a:solidFill>
+                  <a:srgbClr val="F3F4F6"/>
+                </a:solidFill>
+              </a:defRPr>
+            </a:pPr>
+            <a:r>
+              <a:t>Titans siphon active lava or water, mutating the land into Barren Earth.</a:t>
             </a:r>
           </a:p>
           <a:p>
@@ -5944,22 +5944,22 @@
               </a:defRPr>
             </a:pPr>
             <a:r>
-              <a:t>💡 Natural Synergy</a:t>
-            </a:r>
-          </a:p>
-          <a:p>
-            <a:pPr>
-              <a:spcAft>
-                <a:spcPts val="300"/>
-              </a:spcAft>
-              <a:defRPr sz="1150">
-                <a:solidFill>
-                  <a:srgbClr val="F3F4F6"/>
-                </a:solidFill>
-              </a:defRPr>
-            </a:pPr>
-            <a:r>
-              <a:t>Setting tiles ablaze creates hazards to push enemies into, buffs your allied monsters, and generates fuel to cast match-winning Titan finishers.</a:t>
+              <a:t>💡 Master &amp; Monster Dual-Command</a:t>
+            </a:r>
+          </a:p>
+          <a:p>
+            <a:pPr>
+              <a:spcAft>
+                <a:spcPts val="300"/>
+              </a:spcAft>
+              <a:defRPr sz="1150">
+                <a:solidFill>
+                  <a:srgbClr val="F3F4F6"/>
+                </a:solidFill>
+              </a:defRPr>
+            </a:pPr>
+            <a:r>
+              <a:t>The Master sculpts the space and knocks enemies into traps; the Monster holds the frontline, thrives in the hazards, and consumes the land for decisive finishers.</a:t>
             </a:r>
           </a:p>
         </p:txBody>
@@ -6131,7 +6131,7 @@
               </a:defRPr>
             </a:pPr>
             <a:r>
-              <a:t>Target the ground itself to reshape the battlefield, cut off enemy escape routes, and carve lethal molten lava moats.</a:t>
+              <a:t>Target the ground itself to reshape the battlefield, cut off enemy movement paths, and carve lethal molten lava moats.</a:t>
             </a:r>
           </a:p>
           <a:p>
@@ -6215,76 +6215,76 @@
               </a:defRPr>
             </a:pPr>
             <a:r>
-              <a:t>🐉 2. Titan Ecosystems</a:t>
-            </a:r>
-          </a:p>
-          <a:p>
-            <a:pPr>
-              <a:spcAft>
-                <a:spcPts val="300"/>
-              </a:spcAft>
-              <a:defRPr sz="1150">
-                <a:solidFill>
-                  <a:srgbClr val="F3F4F6"/>
-                </a:solidFill>
-              </a:defRPr>
-            </a:pPr>
-            <a:r>
-              <a:t>Colossal allied monsters that feed directly on the environment.</a:t>
-            </a:r>
-          </a:p>
-          <a:p>
-            <a:pPr>
-              <a:spcAft>
-                <a:spcPts val="300"/>
-              </a:spcAft>
-              <a:defRPr sz="1150">
-                <a:solidFill>
-                  <a:srgbClr val="F3F4F6"/>
-                </a:solidFill>
-              </a:defRPr>
-            </a:pPr>
-          </a:p>
-          <a:p>
-            <a:pPr>
-              <a:spcAft>
-                <a:spcPts val="300"/>
-              </a:spcAft>
-              <a:defRPr sz="1150">
-                <a:solidFill>
-                  <a:srgbClr val="F3F4F6"/>
-                </a:solidFill>
-              </a:defRPr>
-            </a:pPr>
-            <a:r>
-              <a:t>The more elemental chaos on the board, the more energy your Titan absorbs for ultimate abilities.</a:t>
-            </a:r>
-          </a:p>
-          <a:p>
-            <a:pPr>
-              <a:spcAft>
-                <a:spcPts val="300"/>
-              </a:spcAft>
-              <a:defRPr sz="1150">
-                <a:solidFill>
-                  <a:srgbClr val="F3F4F6"/>
-                </a:solidFill>
-              </a:defRPr>
-            </a:pPr>
-          </a:p>
-          <a:p>
-            <a:pPr>
-              <a:spcAft>
-                <a:spcPts val="300"/>
-              </a:spcAft>
-              <a:defRPr sz="1150">
-                <a:solidFill>
-                  <a:srgbClr val="F3F4F6"/>
-                </a:solidFill>
-              </a:defRPr>
-            </a:pPr>
-            <a:r>
-              <a:t>Titans are naturally immune to elemental hazards.</a:t>
+              <a:t>🐉 2. Master &amp; Monster Cohorts</a:t>
+            </a:r>
+          </a:p>
+          <a:p>
+            <a:pPr>
+              <a:spcAft>
+                <a:spcPts val="300"/>
+              </a:spcAft>
+              <a:defRPr sz="1150">
+                <a:solidFill>
+                  <a:srgbClr val="F3F4F6"/>
+                </a:solidFill>
+              </a:defRPr>
+            </a:pPr>
+            <a:r>
+              <a:t>Direct dual-command on the hex grid.</a:t>
+            </a:r>
+          </a:p>
+          <a:p>
+            <a:pPr>
+              <a:spcAft>
+                <a:spcPts val="300"/>
+              </a:spcAft>
+              <a:defRPr sz="1150">
+                <a:solidFill>
+                  <a:srgbClr val="F3F4F6"/>
+                </a:solidFill>
+              </a:defRPr>
+            </a:pPr>
+          </a:p>
+          <a:p>
+            <a:pPr>
+              <a:spcAft>
+                <a:spcPts val="300"/>
+              </a:spcAft>
+              <a:defRPr sz="1150">
+                <a:solidFill>
+                  <a:srgbClr val="F3F4F6"/>
+                </a:solidFill>
+              </a:defRPr>
+            </a:pPr>
+            <a:r>
+              <a:t>Players control both the fragile Human Master (spatial control &amp; spells) and colossal allied Monsters (frontline anchors &amp; land harvesters).</a:t>
+            </a:r>
+          </a:p>
+          <a:p>
+            <a:pPr>
+              <a:spcAft>
+                <a:spcPts val="300"/>
+              </a:spcAft>
+              <a:defRPr sz="1150">
+                <a:solidFill>
+                  <a:srgbClr val="F3F4F6"/>
+                </a:solidFill>
+              </a:defRPr>
+            </a:pPr>
+          </a:p>
+          <a:p>
+            <a:pPr>
+              <a:spcAft>
+                <a:spcPts val="300"/>
+              </a:spcAft>
+              <a:defRPr sz="1150">
+                <a:solidFill>
+                  <a:srgbClr val="F3F4F6"/>
+                </a:solidFill>
+              </a:defRPr>
+            </a:pPr>
+            <a:r>
+              <a:t>True tactical monster commanding.</a:t>
             </a:r>
           </a:p>
         </p:txBody>
@@ -6410,7 +6410,7 @@
               </a:defRPr>
             </a:pPr>
             <a:r>
-              <a:t>Knocking them into lava or off cliffs inflicts continuous environmental burns.</a:t>
+              <a:t>Knocking enemies into lava pools or off cliffs inflicts continuous environmental burns.</a:t>
             </a:r>
           </a:p>
         </p:txBody>
@@ -6467,22 +6467,22 @@
               </a:defRPr>
             </a:pPr>
             <a:r>
-              <a:t>⏱️ Fast Action Economy</a:t>
-            </a:r>
-          </a:p>
-          <a:p>
-            <a:pPr>
-              <a:spcAft>
-                <a:spcPts val="300"/>
-              </a:spcAft>
-              <a:defRPr sz="1150">
-                <a:solidFill>
-                  <a:srgbClr val="F3F4F6"/>
-                </a:solidFill>
-              </a:defRPr>
-            </a:pPr>
-            <a:r>
-              <a:t>Every unit gets a clean 1 Move + 1 Combat Action per turn. No menu paralysis, no 45-minute slogs—just tight 10-minute spatial puzzles.</a:t>
+              <a:t>⏱️ Streamlined Turn Economy (Zero Bloat)</a:t>
+            </a:r>
+          </a:p>
+          <a:p>
+            <a:pPr>
+              <a:spcAft>
+                <a:spcPts val="300"/>
+              </a:spcAft>
+              <a:defRPr sz="1150">
+                <a:solidFill>
+                  <a:srgbClr val="F3F4F6"/>
+                </a:solidFill>
+              </a:defRPr>
+            </a:pPr>
+            <a:r>
+              <a:t>Deliberate tactical depth with zero slog. Clean 1 Move + 1 Combat Action per unit, hybrid attack-terraforming, and Ghost UI prediction—respecting player time.</a:t>
             </a:r>
           </a:p>
         </p:txBody>
@@ -6627,6 +6627,21 @@
               </a:defRPr>
             </a:pPr>
             <a:r>
+              <a:t>• Focused 2v2 prototype (Master + Titan vs Boss + Minion)</a:t>
+            </a:r>
+          </a:p>
+          <a:p>
+            <a:pPr>
+              <a:spcAft>
+                <a:spcPts val="300"/>
+              </a:spcAft>
+              <a:defRPr sz="1150">
+                <a:solidFill>
+                  <a:srgbClr val="F3F4F6"/>
+                </a:solidFill>
+              </a:defRPr>
+            </a:pPr>
+            <a:r>
               <a:t>• 3D procedural hex grid with multi-level cliff elevations</a:t>
             </a:r>
           </a:p>
@@ -6672,7 +6687,7 @@
               </a:defRPr>
             </a:pPr>
             <a:r>
-              <a:t>• FFT-style terrain attunement (Flame Surge buffs &amp; immunities)</a:t>
+              <a:t>• Terrain attunement (Flame Surge buffs &amp; immunities)</a:t>
             </a:r>
           </a:p>
           <a:p>
@@ -6789,7 +6804,7 @@
               </a:defRPr>
             </a:pPr>
             <a:r>
-              <a:t>Fireball ignites grass ➔ Shove slams enemy into rock ➔ Dragon siphons lava (+1 Core) ➔ Magma Cataclysm wipes the board!</a:t>
+              <a:t>Master casts Fireball ➔ Shove slams enemy into rock ➔ Dragon siphons lava (+1 Core) ➔ Magma Cataclysm wipes the board!</a:t>
             </a:r>
           </a:p>
         </p:txBody>
@@ -6886,7 +6901,7 @@
               </a:defRPr>
             </a:pPr>
             <a:r>
-              <a:t>Game Design Solutions: Player-First Combat</a:t>
+              <a:t>Game Design Solutions: Streamlined Tactical Flow</a:t>
             </a:r>
           </a:p>
         </p:txBody>
@@ -7198,7 +7213,7 @@
               </a:defRPr>
             </a:pPr>
             <a:r>
-              <a:t>Result: Fast pacing where every single turn feels impactful.</a:t>
+              <a:t>Result: Streamlined combat flow where every turn advances the battle.</a:t>
             </a:r>
           </a:p>
         </p:txBody>
@@ -7271,7 +7286,7 @@
               </a:defRPr>
             </a:pPr>
             <a:r>
-              <a:t>Unit Asymmetry: Shapers vs. Titans</a:t>
+              <a:t>Unit Asymmetry: Masters vs. Monsters</a:t>
             </a:r>
           </a:p>
         </p:txBody>
@@ -7328,49 +7343,49 @@
               </a:defRPr>
             </a:pPr>
             <a:r>
-              <a:t>🧙 Human Commanders (The Shapers)</a:t>
-            </a:r>
-          </a:p>
-          <a:p>
-            <a:pPr>
-              <a:spcAft>
-                <a:spcPts val="300"/>
-              </a:spcAft>
-              <a:defRPr sz="1150">
-                <a:solidFill>
-                  <a:srgbClr val="F3F4F6"/>
-                </a:solidFill>
-              </a:defRPr>
-            </a:pPr>
-            <a:r>
-              <a:t>ROLE: Map Manipulator (Low HP, High Mobility, Spatial Control)</a:t>
-            </a:r>
-          </a:p>
-          <a:p>
-            <a:pPr>
-              <a:spcAft>
-                <a:spcPts val="300"/>
-              </a:spcAft>
-              <a:defRPr sz="1150">
-                <a:solidFill>
-                  <a:srgbClr val="F3F4F6"/>
-                </a:solidFill>
-              </a:defRPr>
-            </a:pPr>
-          </a:p>
-          <a:p>
-            <a:pPr>
-              <a:spcAft>
-                <a:spcPts val="300"/>
-              </a:spcAft>
-              <a:defRPr sz="1150">
-                <a:solidFill>
-                  <a:srgbClr val="F3F4F6"/>
-                </a:solidFill>
-              </a:defRPr>
-            </a:pPr>
-            <a:r>
-              <a:t>Squishy but agile. Casts ranged Fireballs, Water Surges, and Kinetic Pushes to manipulate enemy positioning and shape terrain from afar.</a:t>
+              <a:t>🧙 Human Masters (The Shapers)</a:t>
+            </a:r>
+          </a:p>
+          <a:p>
+            <a:pPr>
+              <a:spcAft>
+                <a:spcPts val="300"/>
+              </a:spcAft>
+              <a:defRPr sz="1150">
+                <a:solidFill>
+                  <a:srgbClr val="F3F4F6"/>
+                </a:solidFill>
+              </a:defRPr>
+            </a:pPr>
+            <a:r>
+              <a:t>ROLE: Spatial Manipulator (Low HP, High Mobility, Map Shaper)</a:t>
+            </a:r>
+          </a:p>
+          <a:p>
+            <a:pPr>
+              <a:spcAft>
+                <a:spcPts val="300"/>
+              </a:spcAft>
+              <a:defRPr sz="1150">
+                <a:solidFill>
+                  <a:srgbClr val="F3F4F6"/>
+                </a:solidFill>
+              </a:defRPr>
+            </a:pPr>
+          </a:p>
+          <a:p>
+            <a:pPr>
+              <a:spcAft>
+                <a:spcPts val="300"/>
+              </a:spcAft>
+              <a:defRPr sz="1150">
+                <a:solidFill>
+                  <a:srgbClr val="F3F4F6"/>
+                </a:solidFill>
+              </a:defRPr>
+            </a:pPr>
+            <a:r>
+              <a:t>Player-controlled caster. Squishy but agile. Casts ranged Fireballs, Water Surges, and Kinetic Pushes to reshape terrain and manipulate enemy positioning.</a:t>
             </a:r>
           </a:p>
         </p:txBody>
@@ -7427,49 +7442,49 @@
               </a:defRPr>
             </a:pPr>
             <a:r>
-              <a:t>🐉 Allied Titans (Colossal Anchors)</a:t>
-            </a:r>
-          </a:p>
-          <a:p>
-            <a:pPr>
-              <a:spcAft>
-                <a:spcPts val="300"/>
-              </a:spcAft>
-              <a:defRPr sz="1150">
-                <a:solidFill>
-                  <a:srgbClr val="F3F4F6"/>
-                </a:solidFill>
-              </a:defRPr>
-            </a:pPr>
-            <a:r>
-              <a:t>ROLE: Frontline Finisher (Colossal 14 HP, Hazard-Immune)</a:t>
-            </a:r>
-          </a:p>
-          <a:p>
-            <a:pPr>
-              <a:spcAft>
-                <a:spcPts val="300"/>
-              </a:spcAft>
-              <a:defRPr sz="1150">
-                <a:solidFill>
-                  <a:srgbClr val="F3F4F6"/>
-                </a:solidFill>
-              </a:defRPr>
-            </a:pPr>
-          </a:p>
-          <a:p>
-            <a:pPr>
-              <a:spcAft>
-                <a:spcPts val="300"/>
-              </a:spcAft>
-              <a:defRPr sz="1150">
-                <a:solidFill>
-                  <a:srgbClr val="F3F4F6"/>
-                </a:solidFill>
-              </a:defRPr>
-            </a:pPr>
-            <a:r>
-              <a:t>Massive tank. Naturally immune to molten lava, holds down the frontline with heavy melee strikes, and harvests land to trigger room-clearing Magma Cataclysms.</a:t>
+              <a:t>🐉 Allied Monsters (The Titans)</a:t>
+            </a:r>
+          </a:p>
+          <a:p>
+            <a:pPr>
+              <a:spcAft>
+                <a:spcPts val="300"/>
+              </a:spcAft>
+              <a:defRPr sz="1150">
+                <a:solidFill>
+                  <a:srgbClr val="F3F4F6"/>
+                </a:solidFill>
+              </a:defRPr>
+            </a:pPr>
+            <a:r>
+              <a:t>ROLE: Frontline Anchor (Colossal 14 HP, Hazard-Immune)</a:t>
+            </a:r>
+          </a:p>
+          <a:p>
+            <a:pPr>
+              <a:spcAft>
+                <a:spcPts val="300"/>
+              </a:spcAft>
+              <a:defRPr sz="1150">
+                <a:solidFill>
+                  <a:srgbClr val="F3F4F6"/>
+                </a:solidFill>
+              </a:defRPr>
+            </a:pPr>
+          </a:p>
+          <a:p>
+            <a:pPr>
+              <a:spcAft>
+                <a:spcPts val="300"/>
+              </a:spcAft>
+              <a:defRPr sz="1150">
+                <a:solidFill>
+                  <a:srgbClr val="F3F4F6"/>
+                </a:solidFill>
+              </a:defRPr>
+            </a:pPr>
+            <a:r>
+              <a:t>Player-controlled behemoth. Naturally immune to molten lava, holds down the frontline with heavy melee strikes, and harvests land to trigger Magma Cataclysms.</a:t>
             </a:r>
           </a:p>
         </p:txBody>
@@ -7526,7 +7541,7 @@
               </a:defRPr>
             </a:pPr>
             <a:r>
-              <a:t>🔥 Dracomancers (Enemy Bosses)</a:t>
+              <a:t>🔥 Dracomancers (Enemy Rival Masters)</a:t>
             </a:r>
           </a:p>
           <a:p>
@@ -7625,7 +7640,7 @@
               </a:defRPr>
             </a:pPr>
             <a:r>
-              <a:t>👿 Demon Slimes (Aggressive Swarmers)</a:t>
+              <a:t>👿 Demon Slimes (Aggressive Minions)</a:t>
             </a:r>
           </a:p>
           <a:p>
@@ -7667,7 +7682,7 @@
               </a:defRPr>
             </a:pPr>
             <a:r>
-              <a:t>Aggressive swarmers that navigate around hazards to flank your Commander and attempt to knock him off elevated plateaus.</a:t>
+              <a:t>Aggressive swarmers that navigate around hazards to flank your Master and attempt to knock him off elevated plateaus.</a:t>
             </a:r>
           </a:p>
         </p:txBody>
@@ -7812,7 +7827,7 @@
               </a:defRPr>
             </a:pPr>
             <a:r>
-              <a:t>Branching expedition map inspired by Slay the Spire and Into the Breach.</a:t>
+              <a:t>Branching expedition map inspired by Slay the Spire and Brigandine.</a:t>
             </a:r>
           </a:p>
           <a:p>
@@ -7923,49 +7938,49 @@
               </a:defRPr>
             </a:pPr>
             <a:r>
-              <a:t>🔮 Spellbooks &amp; Titans</a:t>
-            </a:r>
-          </a:p>
-          <a:p>
-            <a:pPr>
-              <a:spcAft>
-                <a:spcPts val="300"/>
-              </a:spcAft>
-              <a:defRPr sz="1150">
-                <a:solidFill>
-                  <a:srgbClr val="F3F4F6"/>
-                </a:solidFill>
-              </a:defRPr>
-            </a:pPr>
-            <a:r>
-              <a:t>Unlock new elemental disciplines for your Commander (Ice, Lightning, Earth).</a:t>
-            </a:r>
-          </a:p>
-          <a:p>
-            <a:pPr>
-              <a:spcAft>
-                <a:spcPts val="300"/>
-              </a:spcAft>
-              <a:defRPr sz="1150">
-                <a:solidFill>
-                  <a:srgbClr val="F3F4F6"/>
-                </a:solidFill>
-              </a:defRPr>
-            </a:pPr>
-          </a:p>
-          <a:p>
-            <a:pPr>
-              <a:spcAft>
-                <a:spcPts val="300"/>
-              </a:spcAft>
-              <a:defRPr sz="1150">
-                <a:solidFill>
-                  <a:srgbClr val="F3F4F6"/>
-                </a:solidFill>
-              </a:defRPr>
-            </a:pPr>
-            <a:r>
-              <a:t>Hatch and attune new Titan monsters with unique passive immunities and devastating Cataclysm ultimates.</a:t>
+              <a:t>🔮 Spellbooks &amp; Monsters</a:t>
+            </a:r>
+          </a:p>
+          <a:p>
+            <a:pPr>
+              <a:spcAft>
+                <a:spcPts val="300"/>
+              </a:spcAft>
+              <a:defRPr sz="1150">
+                <a:solidFill>
+                  <a:srgbClr val="F3F4F6"/>
+                </a:solidFill>
+              </a:defRPr>
+            </a:pPr>
+            <a:r>
+              <a:t>Unlock new elemental disciplines for your Master (Ice, Lightning, Earth).</a:t>
+            </a:r>
+          </a:p>
+          <a:p>
+            <a:pPr>
+              <a:spcAft>
+                <a:spcPts val="300"/>
+              </a:spcAft>
+              <a:defRPr sz="1150">
+                <a:solidFill>
+                  <a:srgbClr val="F3F4F6"/>
+                </a:solidFill>
+              </a:defRPr>
+            </a:pPr>
+          </a:p>
+          <a:p>
+            <a:pPr>
+              <a:spcAft>
+                <a:spcPts val="300"/>
+              </a:spcAft>
+              <a:defRPr sz="1150">
+                <a:solidFill>
+                  <a:srgbClr val="F3F4F6"/>
+                </a:solidFill>
+              </a:defRPr>
+            </a:pPr>
+            <a:r>
+              <a:t>Hatch, evolve, and attune new Monster cohorts with unique passive immunities and Cataclysm ultimates.</a:t>
             </a:r>
           </a:p>
         </p:txBody>
@@ -8022,76 +8037,49 @@
               </a:defRPr>
             </a:pPr>
             <a:r>
-              <a:t>⏱️ Zero-Grind Pacing</a:t>
-            </a:r>
-          </a:p>
-          <a:p>
-            <a:pPr>
-              <a:spcAft>
-                <a:spcPts val="300"/>
-              </a:spcAft>
-              <a:defRPr sz="1150">
-                <a:solidFill>
-                  <a:srgbClr val="F3F4F6"/>
-                </a:solidFill>
-              </a:defRPr>
-            </a:pPr>
-            <a:r>
-              <a:t>No 20-hour XP grinding.</a:t>
-            </a:r>
-          </a:p>
-          <a:p>
-            <a:pPr>
-              <a:spcAft>
-                <a:spcPts val="300"/>
-              </a:spcAft>
-              <a:defRPr sz="1150">
-                <a:solidFill>
-                  <a:srgbClr val="F3F4F6"/>
-                </a:solidFill>
-              </a:defRPr>
-            </a:pPr>
-          </a:p>
-          <a:p>
-            <a:pPr>
-              <a:spcAft>
-                <a:spcPts val="300"/>
-              </a:spcAft>
-              <a:defRPr sz="1150">
-                <a:solidFill>
-                  <a:srgbClr val="F3F4F6"/>
-                </a:solidFill>
-              </a:defRPr>
-            </a:pPr>
-            <a:r>
-              <a:t>Every skirmish is a tight 10–15 minute spatial challenge.</a:t>
-            </a:r>
-          </a:p>
-          <a:p>
-            <a:pPr>
-              <a:spcAft>
-                <a:spcPts val="300"/>
-              </a:spcAft>
-              <a:defRPr sz="1150">
-                <a:solidFill>
-                  <a:srgbClr val="F3F4F6"/>
-                </a:solidFill>
-              </a:defRPr>
-            </a:pPr>
-          </a:p>
-          <a:p>
-            <a:pPr>
-              <a:spcAft>
-                <a:spcPts val="300"/>
-              </a:spcAft>
-              <a:defRPr sz="1150">
-                <a:solidFill>
-                  <a:srgbClr val="F3F4F6"/>
-                </a:solidFill>
-              </a:defRPr>
-            </a:pPr>
-            <a:r>
-              <a:t>Success is driven by player skill, positioning, and creative terrain combos—never stat checks.</a:t>
+              <a:t>⏱️ Zero-Grind Tactical Depth</a:t>
+            </a:r>
+          </a:p>
+          <a:p>
+            <a:pPr>
+              <a:spcAft>
+                <a:spcPts val="300"/>
+              </a:spcAft>
+              <a:defRPr sz="1150">
+                <a:solidFill>
+                  <a:srgbClr val="F3F4F6"/>
+                </a:solidFill>
+              </a:defRPr>
+            </a:pPr>
+            <a:r>
+              <a:t>No 20-hour stat grinding.</a:t>
+            </a:r>
+          </a:p>
+          <a:p>
+            <a:pPr>
+              <a:spcAft>
+                <a:spcPts val="300"/>
+              </a:spcAft>
+              <a:defRPr sz="1150">
+                <a:solidFill>
+                  <a:srgbClr val="F3F4F6"/>
+                </a:solidFill>
+              </a:defRPr>
+            </a:pPr>
+          </a:p>
+          <a:p>
+            <a:pPr>
+              <a:spcAft>
+                <a:spcPts val="300"/>
+              </a:spcAft>
+              <a:defRPr sz="1150">
+                <a:solidFill>
+                  <a:srgbClr val="F3F4F6"/>
+                </a:solidFill>
+              </a:defRPr>
+            </a:pPr>
+            <a:r>
+              <a:t>Thoughtful, deliberate turn-based tactical battles where success is driven by player skill, positioning, and creative terrain combos—never stat checks.</a:t>
             </a:r>
           </a:p>
         </p:txBody>
@@ -8163,7 +8151,7 @@
               </a:defRPr>
             </a:pPr>
             <a:r>
-              <a:t>Procedural encounter routes, emergent environmental chemistry, and diverse squad combinations ensure no two runs feel identical.</a:t>
+              <a:t>Procedural encounter routes, emergent environmental chemistry, and diverse Master-Monster squad combinations ensure no two runs feel identical.</a:t>
             </a:r>
           </a:p>
         </p:txBody>
@@ -8338,7 +8326,7 @@
               </a:defRPr>
             </a:pPr>
             <a:r>
-              <a:t>How We Differentiate: Replaces 45-min slow AA battle animations with fast 10-min kinetic skirmishes; transforms passive terrain buffs into Active Terraforming.</a:t>
+              <a:t>How We Differentiate: Replaces slow 45-min AA battle animations with streamlined tactical skirmishes; transforms passive terrain buffs into Active Terraforming.</a:t>
             </a:r>
           </a:p>
         </p:txBody>
@@ -8644,7 +8632,7 @@
               </a:defRPr>
             </a:pPr>
             <a:r>
-              <a:t>How We Differentiate: Snappy 10-minute skirmishes designed for modern indie players with zero level-grinding and deeper terrain chemistry.</a:t>
+              <a:t>How We Differentiate: Streamlined tactical flow designed for modern indie players with zero level-grinding and deeper terrain chemistry.</a:t>
             </a:r>
           </a:p>
         </p:txBody>
@@ -8716,7 +8704,7 @@
               </a:defRPr>
             </a:pPr>
             <a:r>
-              <a:t>Players love Brigandine's hex-grid monster fantasy and Into the Breach's puzzle clarity—Elemental Hex Tactics marries both into snappy 10-minute HD-2D matches with active terraforming.</a:t>
+              <a:t>Players love Brigandine's hex-grid monster fantasy and Into the Breach's puzzle clarity—Elemental Hex Tactics marries both into streamlined, deliberate HD-2D matches with active terraforming.</a:t>
             </a:r>
           </a:p>
         </p:txBody>

</xml_diff>

<commit_message>
feat: align Slide 6 with Toge official pitch guide - Why Toge Productions
</commit_message>
<xml_diff>
--- a/ElementalHexTactics_PitchDeck.pptx
+++ b/ElementalHexTactics_PitchDeck.pptx
@@ -858,7 +858,7 @@
           <a:lstStyle/>
           <a:p>
             <a:r>
-              <a:t>Slide 6 outlines our ask: $6,000 in prototype grant funding and production mentorship, in exchange for transparent milestones and Right of First Refusal for a full publishing deal.</a:t>
+              <a:t>Slide 6 outlines our ask: $6,000 in prototype grant funding and production mentorship, explains why Toge is the ideal publisher for this game, and establishes Right of First Refusal for full publishing.</a:t>
             </a:r>
           </a:p>
         </p:txBody>
@@ -6658,8 +6658,65 @@
               </a:defRPr>
             </a:pPr>
             <a:r>
-              <a:t>🤝 Publisher Support &amp; Commercial Path</a:t>
-            </a:r>
+              <a:t>🤝 Why Toge Productions &amp; Partnership</a:t>
+            </a:r>
+          </a:p>
+          <a:p>
+            <a:pPr>
+              <a:spcAft>
+                <a:spcPts val="250"/>
+              </a:spcAft>
+              <a:defRPr sz="1100">
+                <a:solidFill>
+                  <a:srgbClr val="F3F4F6"/>
+                </a:solidFill>
+              </a:defRPr>
+            </a:pPr>
+            <a:r>
+              <a:t>• Why Toge Productions is the Ideal Partner:</a:t>
+            </a:r>
+          </a:p>
+          <a:p>
+            <a:pPr>
+              <a:spcAft>
+                <a:spcPts val="250"/>
+              </a:spcAft>
+              <a:defRPr sz="1100">
+                <a:solidFill>
+                  <a:srgbClr val="F3F4F6"/>
+                </a:solidFill>
+              </a:defRPr>
+            </a:pPr>
+            <a:r>
+              <a:t>  1. Proven Champion of Tactical Depth: Toge published Vanaris Tactics and develops Kriegsfront Tactics. Toge's community is our exact target audience.</a:t>
+            </a:r>
+          </a:p>
+          <a:p>
+            <a:pPr>
+              <a:spcAft>
+                <a:spcPts val="250"/>
+              </a:spcAft>
+              <a:defRPr sz="1100">
+                <a:solidFill>
+                  <a:srgbClr val="F3F4F6"/>
+                </a:solidFill>
+              </a:defRPr>
+            </a:pPr>
+            <a:r>
+              <a:t>  2. Shared Indonesian Indie Heritage: From garage roots to global reach, Toge understands our vision, culture, and production pipeline.</a:t>
+            </a:r>
+          </a:p>
+          <a:p>
+            <a:pPr>
+              <a:spcAft>
+                <a:spcPts val="250"/>
+              </a:spcAft>
+              <a:defRPr sz="1100">
+                <a:solidFill>
+                  <a:srgbClr val="F3F4F6"/>
+                </a:solidFill>
+              </a:defRPr>
+            </a:pPr>
           </a:p>
           <a:p>
             <a:pPr>
@@ -6688,22 +6745,22 @@
               </a:defRPr>
             </a:pPr>
             <a:r>
-              <a:t>  1. Milestone feedback &amp; production mentorship from Toge's veteran producers.</a:t>
-            </a:r>
-          </a:p>
-          <a:p>
-            <a:pPr>
-              <a:spcAft>
-                <a:spcPts val="250"/>
-              </a:spcAft>
-              <a:defRPr sz="1100">
-                <a:solidFill>
-                  <a:srgbClr val="F3F4F6"/>
-                </a:solidFill>
-              </a:defRPr>
-            </a:pPr>
-            <a:r>
-              <a:t>  2. Publishing evaluation and market positioning guidance for Steam Next Fest.</a:t>
+              <a:t>  1. Production mentorship &amp; milestone feedback from veteran producers.</a:t>
+            </a:r>
+          </a:p>
+          <a:p>
+            <a:pPr>
+              <a:spcAft>
+                <a:spcPts val="250"/>
+              </a:spcAft>
+              <a:defRPr sz="1100">
+                <a:solidFill>
+                  <a:srgbClr val="F3F4F6"/>
+                </a:solidFill>
+              </a:defRPr>
+            </a:pPr>
+            <a:r>
+              <a:t>  2. Steam Next Fest positioning and marketing guidance.</a:t>
             </a:r>
           </a:p>
           <a:p>
@@ -6745,37 +6802,22 @@
               </a:defRPr>
             </a:pPr>
             <a:r>
-              <a:t>  1. Right of First Refusal (RoFR) for a full commercial publishing partnership ($50k–$150k USD) to expand into 20+ classes and full continental campaign.</a:t>
-            </a:r>
-          </a:p>
-          <a:p>
-            <a:pPr>
-              <a:spcAft>
-                <a:spcPts val="250"/>
-              </a:spcAft>
-              <a:defRPr sz="1100">
-                <a:solidFill>
-                  <a:srgbClr val="F3F4F6"/>
-                </a:solidFill>
-              </a:defRPr>
-            </a:pPr>
-            <a:r>
-              <a:t>  2. Transparent bi-weekly verified milestone builds.</a:t>
-            </a:r>
-          </a:p>
-          <a:p>
-            <a:pPr>
-              <a:spcAft>
-                <a:spcPts val="250"/>
-              </a:spcAft>
-              <a:defRPr sz="1100">
-                <a:solidFill>
-                  <a:srgbClr val="F3F4F6"/>
-                </a:solidFill>
-              </a:defRPr>
-            </a:pPr>
-            <a:r>
-              <a:t>  3. First access to a unique SEA tactical title marrying classic JRPG nostalgia with modern terraforming mechanics.</a:t>
+              <a:t>  1. Right of First Refusal (RoFR) for full commercial publishing ($50k–$150k USD) to expand into 20+ classes and full campaign.</a:t>
+            </a:r>
+          </a:p>
+          <a:p>
+            <a:pPr>
+              <a:spcAft>
+                <a:spcPts val="250"/>
+              </a:spcAft>
+              <a:defRPr sz="1100">
+                <a:solidFill>
+                  <a:srgbClr val="F3F4F6"/>
+                </a:solidFill>
+              </a:defRPr>
+            </a:pPr>
+            <a:r>
+              <a:t>  2. Transparent bi-weekly verified milestone builds on private branches.</a:t>
             </a:r>
           </a:p>
         </p:txBody>

</xml_diff>